<commit_message>
Strip bogus 10.5281/zenodo.20171725 (mite paper, not AthDGC); disable PDF until hyphen-greek fixed; full clean render
</commit_message>
<xml_diff>
--- a/slides/announcement.pptx
+++ b/slides/announcement.pptx
@@ -4464,8 +4464,10 @@
               <a:t>DOI: </a:t>
             </a:r>
             <a:r>
-              <a:rPr i="1"/>
-              <a:t>Zenodo DOI: pending</a:t>
+              <a:rPr>
+                <a:hlinkClick r:id="rId2"/>
+              </a:rPr>
+              <a:t>10.5281/zenodo.20439182</a:t>
             </a:r>
           </a:p>
         </p:txBody>

</xml_diff>

<commit_message>
AthDGC site update 2026-06-01 01:05 --- clean Quarto render, real Zenodo DOI 10.5281/zenodo.20439182, samples-only public release
</commit_message>
<xml_diff>
--- a/slides/announcement.pptx
+++ b/slides/announcement.pptx
@@ -3186,7 +3186,7 @@
             </a:pPr>
             <a:r>
               <a:rPr/>
-              <a:t>May 31, 2026</a:t>
+              <a:t>June 1, 2026</a:t>
             </a:r>
           </a:p>
         </p:txBody>
@@ -4095,7 +4095,7 @@
             </a:r>
             <a:r>
               <a:rPr/>
-              <a:t> — daily harvest from archive.org, Perseus, First1K, Wikisource, Diorisis</a:t>
+              <a:t> - daily harvest from archive.org, Perseus, First1K, Wikisource, Diorisis</a:t>
             </a:r>
           </a:p>
           <a:p>
@@ -4108,7 +4108,7 @@
             </a:r>
             <a:r>
               <a:rPr/>
-              <a:t> — Greek-script ratio, apparatus-criticus rejection, dedup</a:t>
+              <a:t> - Greek-script ratio, apparatus-criticus rejection, dedup</a:t>
             </a:r>
           </a:p>
           <a:p>
@@ -4121,7 +4121,7 @@
             </a:r>
             <a:r>
               <a:rPr/>
-              <a:t> — PROIEL XML 2.0</a:t>
+              <a:t> - PROIEL XML 2.0</a:t>
             </a:r>
           </a:p>
           <a:p>
@@ -4134,7 +4134,7 @@
             </a:r>
             <a:r>
               <a:rPr/>
-              <a:t> — Stanza </a:t>
+              <a:t> - Stanza </a:t>
             </a:r>
             <a:r>
               <a:rPr>
@@ -4157,7 +4157,7 @@
             </a:r>
             <a:r>
               <a:rPr/>
-              <a:t> — subject, object, oblique, voice, aspect per verb</a:t>
+              <a:t> - subject, object, oblique, voice, aspect per verb</a:t>
             </a:r>
           </a:p>
           <a:p>
@@ -4170,7 +4170,7 @@
             </a:r>
             <a:r>
               <a:rPr/>
-              <a:t> — LaBSE + AwesomeAlign (mBERT)</a:t>
+              <a:t> - LaBSE + AwesomeAlign (mBERT)</a:t>
             </a:r>
           </a:p>
           <a:p>
@@ -4183,7 +4183,7 @@
             </a:r>
             <a:r>
               <a:rPr/>
-              <a:t> — PROIEL XML + JSONL + Qdrant + Neo4j</a:t>
+              <a:t> - PROIEL XML + JSONL + Qdrant + Neo4j</a:t>
             </a:r>
           </a:p>
         </p:txBody>

</xml_diff>

<commit_message>
AthDGC site update 2026-06-01 01:28 --- clean Quarto render, real Zenodo DOI 10.5281/zenodo.20439182, samples-only public release
</commit_message>
<xml_diff>
--- a/slides/announcement.pptx
+++ b/slides/announcement.pptx
@@ -3381,7 +3381,15 @@
             </a:r>
             <a:r>
               <a:rPr/>
-              <a:t> (Project No. 20577) with support from the </a:t>
+              <a:t> under the 3rd Call for HFRI Research Projects to support Post-Doctoral Researchers, </a:t>
+            </a:r>
+            <a:r>
+              <a:rPr b="1"/>
+              <a:t>Project No. 20577</a:t>
+            </a:r>
+            <a:r>
+              <a:rPr/>
+              <a:t>; with complementary support from the </a:t>
             </a:r>
             <a:r>
               <a:rPr b="1"/>
@@ -3406,7 +3414,17 @@
             </a:r>
             <a:r>
               <a:rPr/>
-              <a:t> (Greek national HPC).</a:t>
+              <a:t> (Greek national HPC), allocation </a:t>
+            </a:r>
+            <a:r>
+              <a:rPr>
+                <a:latin typeface="Courier"/>
+              </a:rPr>
+              <a:t>pa260305</a:t>
+            </a:r>
+            <a:r>
+              <a:rPr/>
+              <a:t>.</a:t>
             </a:r>
           </a:p>
         </p:txBody>

</xml_diff>

<commit_message>
AthDGC site update 2026-06-01 02:02 --- clean Quarto render, real Zenodo DOI 10.5281/zenodo.20439182, samples-only public release
</commit_message>
<xml_diff>
--- a/slides/announcement.pptx
+++ b/slides/announcement.pptx
@@ -3521,7 +3521,7 @@
             </a:pPr>
             <a:r>
               <a:rPr/>
-              <a:t>EKPA · Division of Language-Linguistics, Department of English Language and Literature, School of Philosophy</a:t>
+              <a:t>NKUA · Division of Language-Linguistics, Department of English Language and Literature, School of Philosophy</a:t>
             </a:r>
           </a:p>
           <a:p>
@@ -4390,7 +4390,7 @@
             </a:pPr>
             <a:r>
               <a:rPr/>
-              <a:t>EKPA · Athens Digital Glossa Chronos Research Network</a:t>
+              <a:t>NKUA · Athens Digital Glossa Chronos Research Network</a:t>
             </a:r>
           </a:p>
         </p:txBody>

</xml_diff>

<commit_message>
AthDGC site update 2026-06-03 00:51 --- clean Quarto render, real Zenodo DOI 10.5281/zenodo.20439182, samples-only public release
</commit_message>
<xml_diff>
--- a/slides/announcement.pptx
+++ b/slides/announcement.pptx
@@ -3186,7 +3186,7 @@
             </a:pPr>
             <a:r>
               <a:rPr/>
-              <a:t>June 1, 2026</a:t>
+              <a:t>June 3, 2026</a:t>
             </a:r>
           </a:p>
         </p:txBody>
@@ -4462,7 +4462,7 @@
             </a:pPr>
             <a:r>
               <a:rPr/>
-              <a:t>Lavidas, N., Nikiforidou, K., Haug, D., Kulikov, L., Geka, V., Symeonidis, V., Michalareas, T., Chionidi, S., Tsiropina, A., Plakoutsi, E., and Argyropoulos, E. (2026). </a:t>
+              <a:t>Lavidas, N., Nikiforidou, K., Haug, D., Kulikov, L., Geka, V., Symeonidis, V., Michalareas, T., Chionidi, S., Tsiropina, A., Plakoutsi, E., Argyropoulos, E., and the Athens Digital Glossa Chronos Research Network (2026). </a:t>
             </a:r>
             <a:r>
               <a:rPr i="1"/>

</xml_diff>

<commit_message>
AthDGC site update 2026-06-03 22:46 --- clean Quarto render, real Zenodo DOI 10.5281/zenodo.20439182, samples-only public release
</commit_message>
<xml_diff>
--- a/slides/announcement.pptx
+++ b/slides/announcement.pptx
@@ -3269,39 +3269,82 @@
             <a:pPr lvl="0"/>
             <a:r>
               <a:rPr/>
-              <a:t>Press: </a:t>
+              <a:t>Samples: </a:t>
             </a:r>
             <a:r>
               <a:rPr>
                 <a:hlinkClick r:id="rId3"/>
               </a:rPr>
-              <a:t>https://athdgc.github.io/athdgc_press.html</a:t>
+              <a:t>https://athdgc.github.io/samples.html</a:t>
             </a:r>
           </a:p>
           <a:p>
             <a:pPr lvl="0"/>
             <a:r>
               <a:rPr/>
-              <a:t>GitHub: </a:t>
+              <a:t>Tools: </a:t>
             </a:r>
             <a:r>
               <a:rPr>
                 <a:hlinkClick r:id="rId4"/>
               </a:rPr>
-              <a:t>https://github.com/AthDGC</a:t>
+              <a:t>https://athdgc.github.io/tools.html</a:t>
             </a:r>
           </a:p>
           <a:p>
             <a:pPr lvl="0"/>
             <a:r>
               <a:rPr/>
-              <a:t>HFRI project site: </a:t>
+              <a:t>Press kit: </a:t>
             </a:r>
             <a:r>
               <a:rPr>
                 <a:hlinkClick r:id="rId5"/>
               </a:rPr>
-              <a:t>https://athdgc.github.io/hfri2024</a:t>
+              <a:t>https://athdgc.github.io/press.html</a:t>
+            </a:r>
+          </a:p>
+          <a:p>
+            <a:pPr lvl="0"/>
+            <a:r>
+              <a:rPr/>
+              <a:t>Launch report: </a:t>
+            </a:r>
+            <a:r>
+              <a:rPr>
+                <a:hlinkClick r:id="rId6"/>
+              </a:rPr>
+              <a:t>https://athdgc.github.io/data_paper.html</a:t>
+            </a:r>
+          </a:p>
+          <a:p>
+            <a:pPr lvl="0"/>
+            <a:r>
+              <a:rPr/>
+              <a:t>GitHub: </a:t>
+            </a:r>
+            <a:r>
+              <a:rPr>
+                <a:hlinkClick r:id="rId7"/>
+              </a:rPr>
+              <a:t>https://github.com/AthDGC</a:t>
+            </a:r>
+          </a:p>
+          <a:p>
+            <a:pPr lvl="0"/>
+            <a:r>
+              <a:rPr/>
+              <a:t>Hugging Face mirror: </a:t>
+            </a:r>
+            <a:r>
+              <a:rPr>
+                <a:hlinkClick r:id="rId8"/>
+              </a:rPr>
+              <a:t>https://huggingface.co/AthDGC</a:t>
+            </a:r>
+            <a:r>
+              <a:rPr/>
+              <a:t> (in setup; ships at v0.5)</a:t>
             </a:r>
           </a:p>
         </p:txBody>

</xml_diff>

<commit_message>
AthDGC site update 2026-06-05 01:29 --- clean Quarto render, real Zenodo DOI 10.5281/zenodo.20439182, samples-only public release
</commit_message>
<xml_diff>
--- a/slides/announcement.pptx
+++ b/slides/announcement.pptx
@@ -3186,7 +3186,7 @@
             </a:pPr>
             <a:r>
               <a:rPr/>
-              <a:t>June 4, 2026</a:t>
+              <a:t>June 5, 2026</a:t>
             </a:r>
           </a:p>
         </p:txBody>
@@ -3334,7 +3334,7 @@
             <a:pPr lvl="0"/>
             <a:r>
               <a:rPr/>
-              <a:t>Hugging Face mirror: </a:t>
+              <a:t>Hugging Face (a public hosting platform for machine-learning models and datasets) mirror: </a:t>
             </a:r>
             <a:r>
               <a:rPr>
@@ -3453,11 +3453,11 @@
             </a:r>
             <a:r>
               <a:rPr b="1"/>
-              <a:t>GRNET ARIS</a:t>
-            </a:r>
-            <a:r>
-              <a:rPr/>
-              <a:t> (Greek national HPC), allocation </a:t>
+              <a:t>GRNET ARIS (the Greek national high-performance computing cluster, run by GRNET)</a:t>
+            </a:r>
+            <a:r>
+              <a:rPr/>
+              <a:t> (Greek national HPC (high-performance computing, i.e. a cluster of fast machines used for heavy computation)), allocation </a:t>
             </a:r>
             <a:r>
               <a:rPr>
@@ -3551,7 +3551,7 @@
             </a:r>
             <a:r>
               <a:rPr i="1"/>
-              <a:t>Athens-PROIEL</a:t>
+              <a:t>Athens-PROIEL (the dependency-treebank (a collection of sentences whose grammatical structure has been analysed and stored) standard for early Indo-European languages, developed at Oslo)</a:t>
             </a:r>
             <a:r>
               <a:rPr/>
@@ -3657,7 +3657,7 @@
             </a:r>
             <a:r>
               <a:rPr b="1"/>
-              <a:t>PROIEL XML 2.0</a:t>
+              <a:t>PROIEL XML 2.0 (the file format that stores each sentence as a tree of word-by-word grammatical relations, developed at Oslo)</a:t>
             </a:r>
             <a:r>
               <a:rPr/>
@@ -3684,21 +3684,21 @@
             <a:pPr lvl="0"/>
             <a:r>
               <a:rPr/>
-              <a:t>LightSIDE-compatible feature extraction + classifier training</a:t>
+              <a:t>LightSIDE (an open-source text-mining workbench developed at Carnegie Mellon)-compatible feature extraction + classifier training</a:t>
             </a:r>
           </a:p>
           <a:p>
             <a:pPr lvl="0"/>
             <a:r>
               <a:rPr/>
-              <a:t>NoSketch-style concordancer</a:t>
+              <a:t>NoSketch-style concordancer (a search tool that shows every occurrence of a word in its surrounding context)</a:t>
             </a:r>
           </a:p>
           <a:p>
             <a:pPr lvl="0"/>
             <a:r>
               <a:rPr/>
-              <a:t>Fine-tuned Stanza checkpoints (Byzantine, Late-Byzantine, Modern adaptations)</a:t>
+              <a:t>Fine-tuned (further trained on new data to adapt it to a particular text type) Stanza (Stanford’s open-source Python pipeline that automatically tags, lemmatises, and parses sentences) checkpoints (Byzantine, Late-Byzantine, Modern adaptations)</a:t>
             </a:r>
           </a:p>
           <a:p>
@@ -3712,14 +3712,14 @@
             <a:pPr lvl="0"/>
             <a:r>
               <a:rPr/>
-              <a:t>Cross-lingual alignment viewer (Neo4j)</a:t>
+              <a:t>Cross-lingual alignment (matching corresponding words or sentences between texts in different languages) viewer (Neo4j (a graph database that stores data as nodes and connections rather than as tables))</a:t>
             </a:r>
           </a:p>
           <a:p>
             <a:pPr lvl="0"/>
             <a:r>
               <a:rPr/>
-              <a:t>Quarto template pack for any DH project (this very deck is built with it)</a:t>
+              <a:t>Quarto (an open-source publishing system that builds websites, slides, papers, and posters from a single source) template pack for any DH project (this very deck is built with it)</a:t>
             </a:r>
           </a:p>
         </p:txBody>
@@ -4231,7 +4231,7 @@
             </a:r>
             <a:r>
               <a:rPr/>
-              <a:t> - LaBSE + AwesomeAlign (mBERT)</a:t>
+              <a:t> - LaBSE (a multilingual sentence-embedding model that maps sentences from many languages into a common vector space) + AwesomeAlign (a word-alignment procedure that uses multilingual-BERT attention to match words across translations) (mBERT)</a:t>
             </a:r>
           </a:p>
           <a:p>
@@ -4244,7 +4244,7 @@
             </a:r>
             <a:r>
               <a:rPr/>
-              <a:t> - PROIEL XML + JSONL + Qdrant + Neo4j</a:t>
+              <a:t> - PROIEL XML + JSONL (a plain-text data format that stores one record per line) + Qdrant + Neo4j</a:t>
             </a:r>
           </a:p>
         </p:txBody>
@@ -4336,7 +4336,7 @@
             <a:pPr lvl="0"/>
             <a:r>
               <a:rPr b="1"/>
-              <a:t>Argument structure</a:t>
+              <a:t>Argument structure (the set of obligatory and optional partners a verb requires, e.g. subject, object, oblique)</a:t>
             </a:r>
             <a:r>
               <a:rPr/>
@@ -4513,7 +4513,7 @@
             </a:r>
             <a:r>
               <a:rPr/>
-              <a:t>. Zenodo.</a:t>
+              <a:t>. Zenodo (an open research-data repository hosted at CERN that mints permanent DOIs).</a:t>
             </a:r>
           </a:p>
           <a:p>
@@ -4522,7 +4522,7 @@
             </a:pPr>
             <a:r>
               <a:rPr/>
-              <a:t>DOI: </a:t>
+              <a:t>DOI (Digital Object Identifier, a permanent web link for a published artefact): </a:t>
             </a:r>
             <a:r>
               <a:rPr>

</xml_diff>

<commit_message>
AthDGC site update 2026-06-05 22:22 --- clean Quarto render, real Zenodo DOI 10.5281/zenodo.20439182, samples-only public release
</commit_message>
<xml_diff>
--- a/slides/announcement.pptx
+++ b/slides/announcement.pptx
@@ -3964,7 +3964,7 @@
                       </a:pPr>
                       <a:r>
                         <a:rPr/>
-                        <a:t>Total corpus rows</a:t>
+                        <a:t>Greek periods covered</a:t>
                       </a:r>
                     </a:p>
                   </a:txBody>
@@ -3979,71 +3979,7 @@
                       </a:pPr>
                       <a:r>
                         <a:rPr/>
-                        <a:t>89.9 M</a:t>
-                      </a:r>
-                    </a:p>
-                  </a:txBody>
-                </a:tc>
-              </a:tr>
-              <a:tr h="0">
-                <a:tc>
-                  <a:txBody>
-                    <a:bodyPr/>
-                    <a:lstStyle/>
-                    <a:p>
-                      <a:pPr lvl="0" indent="0" marL="0">
-                        <a:buNone/>
-                      </a:pPr>
-                      <a:r>
-                        <a:rPr/>
-                        <a:t>Annotated Greek rows</a:t>
-                      </a:r>
-                    </a:p>
-                  </a:txBody>
-                </a:tc>
-                <a:tc>
-                  <a:txBody>
-                    <a:bodyPr/>
-                    <a:lstStyle/>
-                    <a:p>
-                      <a:pPr lvl="0" indent="0" marL="0">
-                        <a:buNone/>
-                      </a:pPr>
-                      <a:r>
-                        <a:rPr/>
-                        <a:t>4.08 M</a:t>
-                      </a:r>
-                    </a:p>
-                  </a:txBody>
-                </a:tc>
-              </a:tr>
-              <a:tr h="0">
-                <a:tc>
-                  <a:txBody>
-                    <a:bodyPr/>
-                    <a:lstStyle/>
-                    <a:p>
-                      <a:pPr lvl="0" indent="0" marL="0">
-                        <a:buNone/>
-                      </a:pPr>
-                      <a:r>
-                        <a:rPr/>
-                        <a:t>NT-aligned Greek verses</a:t>
-                      </a:r>
-                    </a:p>
-                  </a:txBody>
-                </a:tc>
-                <a:tc>
-                  <a:txBody>
-                    <a:bodyPr/>
-                    <a:lstStyle/>
-                    <a:p>
-                      <a:pPr lvl="0" indent="0" marL="0">
-                        <a:buNone/>
-                      </a:pPr>
-                      <a:r>
-                        <a:rPr/>
-                        <a:t>6,861</a:t>
+                        <a:t>8 (Archaic - Modern)</a:t>
                       </a:r>
                     </a:p>
                   </a:txBody>
@@ -4075,7 +4011,39 @@
                       </a:pPr>
                       <a:r>
                         <a:rPr/>
-                        <a:t>4</a:t>
+                        <a:t>4 (Latin Vulgate, Gothic Wulfila, OCS Marianus, Classical Armenian in ingestion)</a:t>
+                      </a:r>
+                    </a:p>
+                  </a:txBody>
+                </a:tc>
+              </a:tr>
+              <a:tr h="0">
+                <a:tc>
+                  <a:txBody>
+                    <a:bodyPr/>
+                    <a:lstStyle/>
+                    <a:p>
+                      <a:pPr lvl="0" indent="0" marL="0">
+                        <a:buNone/>
+                      </a:pPr>
+                      <a:r>
+                        <a:rPr/>
+                        <a:t>Per-witness verse counts</a:t>
+                      </a:r>
+                    </a:p>
+                  </a:txBody>
+                </a:tc>
+                <a:tc>
+                  <a:txBody>
+                    <a:bodyPr/>
+                    <a:lstStyle/>
+                    <a:p>
+                      <a:pPr lvl="0" indent="0" marL="0">
+                        <a:buNone/>
+                      </a:pPr>
+                      <a:r>
+                        <a:rPr/>
+                        <a:t>v0.5 release notes (post-ARIS audit)</a:t>
                       </a:r>
                     </a:p>
                   </a:txBody>

</xml_diff>

<commit_message>
AthDGC site update 2026-06-07 03:11 --- clean Quarto render, real Zenodo DOI 10.5281/zenodo.20439182, samples-only public release
</commit_message>
<xml_diff>
--- a/slides/announcement.pptx
+++ b/slides/announcement.pptx
@@ -3543,7 +3543,7 @@
             </a:r>
             <a:r>
               <a:rPr b="1"/>
-              <a:t>Athens Diachronic Glossa Chronos</a:t>
+              <a:t>Athens Digital Glossa Chronos</a:t>
             </a:r>
             <a:r>
               <a:rPr/>
@@ -4477,7 +4477,7 @@
             </a:r>
             <a:r>
               <a:rPr i="1"/>
-              <a:t>AthDGC: Athens Diachronic Glossa Chronos</a:t>
+              <a:t>AthDGC: Athens Digital Glossa Chronos</a:t>
             </a:r>
             <a:r>
               <a:rPr/>

</xml_diff>

<commit_message>
AthDGC site update 2026-06-10 19:19 --- clean Quarto render, real Zenodo DOI 10.5281/zenodo.20439182, samples-only public release
</commit_message>
<xml_diff>
--- a/slides/announcement.pptx
+++ b/slides/announcement.pptx
@@ -3186,7 +3186,7 @@
             </a:pPr>
             <a:r>
               <a:rPr/>
-              <a:t>June 9, 2026</a:t>
+              <a:t>June 10, 2026</a:t>
             </a:r>
           </a:p>
         </p:txBody>
@@ -3698,7 +3698,7 @@
             <a:pPr lvl="0"/>
             <a:r>
               <a:rPr/>
-              <a:t>Fine-tuned (further trained on new data to adapt it to a particular text type) Stanza (Stanford’s open-source Python pipeline that automatically tags, lemmatises, and parses sentences) checkpoints (Byzantine, Late-Byzantine, Modern adaptations)</a:t>
+              <a:t>Fine-tuned (further trained on new data to adapt it to a particular text type) Stanza (Stanford’s open-source Python workflow that automatically tags, lemmatises, and parses sentences) checkpoints (Byzantine, Late-Byzantine, Modern adaptations)</a:t>
             </a:r>
           </a:p>
           <a:p>
@@ -4095,7 +4095,7 @@
             </a:pPr>
             <a:r>
               <a:rPr/>
-              <a:t>Pipeline</a:t>
+              <a:t>Workflow</a:t>
             </a:r>
           </a:p>
         </p:txBody>
@@ -4124,7 +4124,7 @@
             </a:r>
             <a:r>
               <a:rPr/>
-              <a:t> - daily harvest from archive.org, Perseus, First1K, Wikisource, Diorisis</a:t>
+              <a:t>, daily harvest from archive.org, Perseus, First1K, Wikisource, Diorisis</a:t>
             </a:r>
           </a:p>
           <a:p>
@@ -4137,7 +4137,7 @@
             </a:r>
             <a:r>
               <a:rPr/>
-              <a:t> - Greek-script ratio, apparatus-criticus rejection, dedup</a:t>
+              <a:t>, Greek-script ratio, apparatus-criticus rejection, dedup</a:t>
             </a:r>
           </a:p>
           <a:p>
@@ -4150,7 +4150,7 @@
             </a:r>
             <a:r>
               <a:rPr/>
-              <a:t> - PROIEL XML 2.0</a:t>
+              <a:t>, PROIEL XML 2.0</a:t>
             </a:r>
           </a:p>
           <a:p>
@@ -4163,7 +4163,7 @@
             </a:r>
             <a:r>
               <a:rPr/>
-              <a:t> - Stanza </a:t>
+              <a:t>, Stanza </a:t>
             </a:r>
             <a:r>
               <a:rPr>
@@ -4186,7 +4186,7 @@
             </a:r>
             <a:r>
               <a:rPr/>
-              <a:t> - subject, object, oblique, voice, aspect per verb</a:t>
+              <a:t>, subject, object, oblique, voice, aspect per verb</a:t>
             </a:r>
           </a:p>
           <a:p>
@@ -4199,7 +4199,7 @@
             </a:r>
             <a:r>
               <a:rPr/>
-              <a:t> - LaBSE (a multilingual sentence-embedding model that maps sentences from many languages into a common vector space) + AwesomeAlign (a word-alignment procedure that uses multilingual-BERT attention to match words across translations) (mBERT)</a:t>
+              <a:t>, LaBSE (a multilingual sentence-embedding model that maps sentences from many languages into a common vector space) + AwesomeAlign (a word-alignment procedure that uses multilingual-BERT attention to match words across translations) (mBERT)</a:t>
             </a:r>
           </a:p>
           <a:p>
@@ -4212,7 +4212,7 @@
             </a:r>
             <a:r>
               <a:rPr/>
-              <a:t> - PROIEL XML + JSONL (a plain-text data format that stores one record per line) + Qdrant + Neo4j</a:t>
+              <a:t>, PROIEL XML + JSONL (a plain-text data format that stores one record per line) + Qdrant + Neo4j</a:t>
             </a:r>
           </a:p>
         </p:txBody>

</xml_diff>